<commit_message>
deck: 60Cr ask + weekly-at-source collection (repo copy was the 18 Jul build)
</commit_message>
<xml_diff>
--- a/public/RasoiCapital_PitchDeck.pptx
+++ b/public/RasoiCapital_PitchDeck.pptx
@@ -3048,7 +3048,7 @@
                 <a:ea typeface="Calibri" pitchFamily="34" charset="-122"/>
                 <a:cs typeface="Calibri" pitchFamily="34" charset="-120"/>
               </a:rPr>
-              <a:t>₹50 Cr</a:t>
+              <a:t>₹60 Cr</a:t>
             </a:r>
             <a:endParaRPr lang="en-US" sz="1500" dirty="0"/>
           </a:p>
@@ -3390,7 +3390,7 @@
                 <a:ea typeface="Calibri" pitchFamily="34" charset="-122"/>
                 <a:cs typeface="Calibri" pitchFamily="34" charset="-120"/>
               </a:rPr>
-              <a:t>Nexus AI  ·  Bengaluru  ·  Investor Presentation  ·  June 2026</a:t>
+              <a:t>Nexus AI  ·  Bengaluru  ·  Investor Presentation  ·  July 2026</a:t>
             </a:r>
             <a:endParaRPr lang="en-US" sz="1000" dirty="0"/>
           </a:p>
@@ -7892,7 +7892,7 @@
                 <a:ea typeface="Calibri" pitchFamily="34" charset="-122"/>
                 <a:cs typeface="Calibri" pitchFamily="34" charset="-120"/>
               </a:rPr>
-              <a:t>repeat borrower · known daily-payment history</a:t>
+              <a:t>repeat borrower · known weekly-payment history</a:t>
             </a:r>
             <a:endParaRPr lang="en-US" sz="880" dirty="0"/>
           </a:p>
@@ -9446,7 +9446,7 @@
                 <a:ea typeface="Calibri" pitchFamily="34" charset="-122"/>
                 <a:cs typeface="Calibri" pitchFamily="34" charset="-120"/>
               </a:rPr>
-              <a:t>₹50 Cr — regulation-anchored, loan-deployed.</a:t>
+              <a:t>₹60 Cr — regulation-anchored, loan-deployed.</a:t>
             </a:r>
             <a:endParaRPr lang="en-US" sz="2700" dirty="0"/>
           </a:p>
@@ -9610,7 +9610,7 @@
                 <a:ea typeface="Calibri" pitchFamily="34" charset="-122"/>
                 <a:cs typeface="Calibri" pitchFamily="34" charset="-120"/>
               </a:rPr>
-              <a:t>52%</a:t>
+              <a:t>60%</a:t>
             </a:r>
             <a:endParaRPr lang="en-US" sz="1000" dirty="0"/>
           </a:p>
@@ -9649,7 +9649,7 @@
                 <a:ea typeface="Calibri" pitchFamily="34" charset="-122"/>
                 <a:cs typeface="Calibri" pitchFamily="34" charset="-120"/>
               </a:rPr>
-              <a:t>₹14 Cr–₹28 Cr</a:t>
+              <a:t>₹22 Cr–₹36 Cr</a:t>
             </a:r>
             <a:endParaRPr lang="en-US" sz="850" dirty="0"/>
           </a:p>
@@ -9813,7 +9813,7 @@
                 <a:ea typeface="Calibri" pitchFamily="34" charset="-122"/>
                 <a:cs typeface="Calibri" pitchFamily="34" charset="-120"/>
               </a:rPr>
-              <a:t>27%</a:t>
+              <a:t>20%</a:t>
             </a:r>
             <a:endParaRPr lang="en-US" sz="1000" dirty="0"/>
           </a:p>
@@ -10055,7 +10055,7 @@
                 <a:ea typeface="Calibri" pitchFamily="34" charset="-122"/>
                 <a:cs typeface="Calibri" pitchFamily="34" charset="-120"/>
               </a:rPr>
-              <a:t>₹2.5 Cr–₹4 Cr</a:t>
+              <a:t>₹3 Cr–₹5 Cr</a:t>
             </a:r>
             <a:endParaRPr lang="en-US" sz="850" dirty="0"/>
           </a:p>
@@ -10258,7 +10258,7 @@
                 <a:ea typeface="Calibri" pitchFamily="34" charset="-122"/>
                 <a:cs typeface="Calibri" pitchFamily="34" charset="-120"/>
               </a:rPr>
-              <a:t>₹2 Cr–₹3.5 Cr</a:t>
+              <a:t>₹2.5 Cr–₹4 Cr</a:t>
             </a:r>
             <a:endParaRPr lang="en-US" sz="850" dirty="0"/>
           </a:p>
@@ -10422,7 +10422,7 @@
                 <a:ea typeface="Calibri" pitchFamily="34" charset="-122"/>
                 <a:cs typeface="Calibri" pitchFamily="34" charset="-120"/>
               </a:rPr>
-              <a:t>6%</a:t>
+              <a:t>5%</a:t>
             </a:r>
             <a:endParaRPr lang="en-US" sz="1000" dirty="0"/>
           </a:p>
@@ -10461,7 +10461,7 @@
                 <a:ea typeface="Calibri" pitchFamily="34" charset="-122"/>
                 <a:cs typeface="Calibri" pitchFamily="34" charset="-120"/>
               </a:rPr>
-              <a:t>₹1.5 Cr–₹2.5 Cr</a:t>
+              <a:t>₹2 Cr–₹3 Cr</a:t>
             </a:r>
             <a:endParaRPr lang="en-US" sz="850" dirty="0"/>
           </a:p>
@@ -20849,7 +20849,7 @@
                 <a:ea typeface="Calibri" pitchFamily="34" charset="-122"/>
                 <a:cs typeface="Calibri" pitchFamily="34" charset="-120"/>
               </a:rPr>
-              <a:t>Daily EMI</a:t>
+              <a:t>Weekly EMI</a:t>
             </a:r>
             <a:endParaRPr lang="en-US" sz="1000" dirty="0"/>
           </a:p>
@@ -20888,7 +20888,7 @@
                 <a:ea typeface="Calibri" pitchFamily="34" charset="-122"/>
                 <a:cs typeface="Calibri" pitchFamily="34" charset="-120"/>
               </a:rPr>
-              <a:t>≈ ₹3,500/day at 9 PM</a:t>
+              <a:t>≈ ₹24,500/week at source</a:t>
             </a:r>
             <a:endParaRPr lang="en-US" sz="1000" dirty="0"/>
           </a:p>
@@ -22287,7 +22287,7 @@
                 <a:ea typeface="Calibri" pitchFamily="34" charset="-122"/>
                 <a:cs typeface="Calibri" pitchFamily="34" charset="-120"/>
               </a:rPr>
-              <a:t>Zero daily misses</a:t>
+              <a:t>Zero weekly misses</a:t>
             </a:r>
             <a:endParaRPr lang="en-US" sz="1000" dirty="0"/>
           </a:p>
@@ -22497,7 +22497,7 @@
                 <a:ea typeface="Calibri" pitchFamily="34" charset="-122"/>
                 <a:cs typeface="Calibri" pitchFamily="34" charset="-120"/>
               </a:rPr>
-              <a:t>Daily misses, monthly clean</a:t>
+              <a:t>Weekly misses, monthly clean</a:t>
             </a:r>
             <a:endParaRPr lang="en-US" sz="1000" dirty="0"/>
           </a:p>

</xml_diff>

<commit_message>
deck: strip emoji ? boxes, keep checkmarks
</commit_message>
<xml_diff>
--- a/public/RasoiCapital_PitchDeck.pptx
+++ b/public/RasoiCapital_PitchDeck.pptx
@@ -4939,7 +4939,7 @@
                 <a:ea typeface="Calibri" pitchFamily="34" charset="-122"/>
                 <a:cs typeface="Calibri" pitchFamily="34" charset="-120"/>
               </a:rPr>
-              <a:t>✓ Claude</a:t>
+              <a:t>✓ Rasoi IQ</a:t>
             </a:r>
             <a:endParaRPr lang="en-US" sz="900" dirty="0"/>
           </a:p>
@@ -6959,7 +6959,7 @@
                 <a:ea typeface="Calibri" pitchFamily="34" charset="-122"/>
                 <a:cs typeface="Calibri" pitchFamily="34" charset="-120"/>
               </a:rPr>
-              <a:t>Cycle-1 illustrative · Bucket C · ₹7L · 6 months · 19% p.a. + 2.5% PF</a:t>
+              <a:t>Cycle-1 illustrative · Bucket C · ₹7L · 24 months · 19% p.a. + 2.5% PF</a:t>
             </a:r>
             <a:endParaRPr lang="en-US" sz="1300" dirty="0"/>
           </a:p>
@@ -7020,7 +7020,7 @@
                 <a:ea typeface="Calibri" pitchFamily="34" charset="-122"/>
                 <a:cs typeface="Calibri" pitchFamily="34" charset="-120"/>
               </a:rPr>
-              <a:t>Interest income (6 mo)</a:t>
+              <a:t>Interest income (24 mo)</a:t>
             </a:r>
             <a:endParaRPr lang="en-US" sz="1050" dirty="0"/>
           </a:p>
@@ -7059,7 +7059,7 @@
                 <a:ea typeface="Calibri" pitchFamily="34" charset="-122"/>
                 <a:cs typeface="Calibri" pitchFamily="34" charset="-120"/>
               </a:rPr>
-              <a:t>+ ₹66,500</a:t>
+              <a:t>+ ₹1,46,900</a:t>
             </a:r>
             <a:endParaRPr lang="en-US" sz="1100" dirty="0"/>
           </a:p>
@@ -7220,7 +7220,7 @@
                 <a:ea typeface="Calibri" pitchFamily="34" charset="-122"/>
                 <a:cs typeface="Calibri" pitchFamily="34" charset="-120"/>
               </a:rPr>
-              <a:t>Cost of debt capital (~10%)</a:t>
+              <a:t>Cost of debt capital (~9.5%)</a:t>
             </a:r>
             <a:endParaRPr lang="en-US" sz="1050" dirty="0"/>
           </a:p>
@@ -7259,7 +7259,7 @@
                 <a:ea typeface="Calibri" pitchFamily="34" charset="-122"/>
                 <a:cs typeface="Calibri" pitchFamily="34" charset="-120"/>
               </a:rPr>
-              <a:t>− ₹35,000</a:t>
+              <a:t>− ₹73,400</a:t>
             </a:r>
             <a:endParaRPr lang="en-US" sz="1100" dirty="0"/>
           </a:p>
@@ -7320,7 +7320,7 @@
                 <a:ea typeface="Calibri" pitchFamily="34" charset="-122"/>
                 <a:cs typeface="Calibri" pitchFamily="34" charset="-120"/>
               </a:rPr>
-              <a:t>Opex + FSA + collections</a:t>
+              <a:t>Collection + opex + FSA</a:t>
             </a:r>
             <a:endParaRPr lang="en-US" sz="1050" dirty="0"/>
           </a:p>
@@ -7359,7 +7359,7 @@
                 <a:ea typeface="Calibri" pitchFamily="34" charset="-122"/>
                 <a:cs typeface="Calibri" pitchFamily="34" charset="-120"/>
               </a:rPr>
-              <a:t>− ₹4,200</a:t>
+              <a:t>− ₹35,000</a:t>
             </a:r>
             <a:endParaRPr lang="en-US" sz="1100" dirty="0"/>
           </a:p>
@@ -7420,7 +7420,7 @@
                 <a:ea typeface="Calibri" pitchFamily="34" charset="-122"/>
                 <a:cs typeface="Calibri" pitchFamily="34" charset="-120"/>
               </a:rPr>
-              <a:t>Expected credit loss (provision)</a:t>
+              <a:t>Expected credit loss (4%)</a:t>
             </a:r>
             <a:endParaRPr lang="en-US" sz="1050" dirty="0"/>
           </a:p>
@@ -7459,7 +7459,7 @@
                 <a:ea typeface="Calibri" pitchFamily="34" charset="-122"/>
                 <a:cs typeface="Calibri" pitchFamily="34" charset="-120"/>
               </a:rPr>
-              <a:t>− ₹3,500</a:t>
+              <a:t>− ₹28,000</a:t>
             </a:r>
             <a:endParaRPr lang="en-US" sz="1100" dirty="0"/>
           </a:p>
@@ -7559,7 +7559,7 @@
                 <a:ea typeface="Calibri" pitchFamily="34" charset="-122"/>
                 <a:cs typeface="Calibri" pitchFamily="34" charset="-120"/>
               </a:rPr>
-              <a:t>≈ ₹41,300</a:t>
+              <a:t>≈ ₹28,000</a:t>
             </a:r>
             <a:endParaRPr lang="en-US" sz="1500" dirty="0"/>
           </a:p>
@@ -7745,7 +7745,7 @@
                 <a:ea typeface="Calibri" pitchFamily="34" charset="-122"/>
                 <a:cs typeface="Calibri" pitchFamily="34" charset="-120"/>
               </a:rPr>
-              <a:t>6 months · prove-out · collateral by bucket</a:t>
+              <a:t>24 months · prove-out · collateral by bucket</a:t>
             </a:r>
             <a:endParaRPr lang="en-US" sz="880" dirty="0"/>
           </a:p>
@@ -9527,7 +9527,7 @@
                 <a:ea typeface="Calibri" pitchFamily="34" charset="-122"/>
                 <a:cs typeface="Calibri" pitchFamily="34" charset="-120"/>
               </a:rPr>
-              <a:t>First ~5,000 loans · Bengaluru → 4 cities · proves the book for debt lines &amp; co-lending</a:t>
+              <a:t>First ~3,000 loans (₹150 Cr Y1) · Bengaluru → 4 cities · proves the book for debt lines &amp; co-lending</a:t>
             </a:r>
             <a:endParaRPr lang="en-US" sz="850" dirty="0"/>
           </a:p>
@@ -10696,7 +10696,7 @@
                 <a:ea typeface="Calibri" pitchFamily="34" charset="-122"/>
                 <a:cs typeface="Calibri" pitchFamily="34" charset="-120"/>
               </a:rPr>
-              <a:t>From licence to ₹150 Cr AUM in 24 months.</a:t>
+              <a:t>From licence to ₹560 Cr AUM in 24 months.</a:t>
             </a:r>
             <a:endParaRPr lang="en-US" sz="2700" dirty="0"/>
           </a:p>
@@ -10941,7 +10941,7 @@
                 <a:ea typeface="Calibri" pitchFamily="34" charset="-122"/>
                 <a:cs typeface="Calibri" pitchFamily="34" charset="-120"/>
               </a:rPr>
-              <a:t>Bengaluru pilot: 200 loans, ₹6 Cr</a:t>
+              <a:t>Bengaluru pilot: 1,000 loans, ₹50 Cr</a:t>
             </a:r>
             <a:endParaRPr lang="en-US" sz="860" dirty="0"/>
           </a:p>
@@ -11311,7 +11311,7 @@
                 <a:ea typeface="Calibri" pitchFamily="34" charset="-122"/>
                 <a:cs typeface="Calibri" pitchFamily="34" charset="-120"/>
               </a:rPr>
-              <a:t>2,500 loans · ₹35 Cr AUM</a:t>
+              <a:t>3,000 loans · ₹150 Cr AUM (end Y1)</a:t>
             </a:r>
             <a:endParaRPr lang="en-US" sz="860" dirty="0"/>
           </a:p>
@@ -11740,7 +11740,7 @@
                 <a:ea typeface="Calibri" pitchFamily="34" charset="-122"/>
                 <a:cs typeface="Calibri" pitchFamily="34" charset="-120"/>
               </a:rPr>
-              <a:t>₹80 Cr AUM on 2× leverage</a:t>
+              <a:t>₹300 Cr AUM on 2× leverage</a:t>
             </a:r>
             <a:endParaRPr lang="en-US" sz="860" dirty="0"/>
           </a:p>
@@ -11992,7 +11992,7 @@
                 <a:ea typeface="Calibri" pitchFamily="34" charset="-122"/>
                 <a:cs typeface="Calibri" pitchFamily="34" charset="-120"/>
               </a:rPr>
-              <a:t>₹150 Cr AUM · 12,000+ active loans</a:t>
+              <a:t>₹560 Cr AUM · 10,500+ active loans</a:t>
             </a:r>
             <a:endParaRPr lang="en-US" sz="860" dirty="0"/>
           </a:p>
@@ -12966,7 +12966,7 @@
                 <a:ea typeface="Calibri" pitchFamily="34" charset="-122"/>
                 <a:cs typeface="Calibri" pitchFamily="34" charset="-120"/>
               </a:rPr>
-              <a:t>🎯  Try it before you decide:  </a:t>
+              <a:t>Try it before you decide:</a:t>
             </a:r>
             <a:pPr indent="0" marL="0">
               <a:buNone/>
@@ -15552,7 +15552,7 @@
                 <a:ea typeface="Calibri" pitchFamily="34" charset="-122"/>
                 <a:cs typeface="Calibri" pitchFamily="34" charset="-120"/>
               </a:rPr>
-              <a:t>🎯  DEMO MOMENT №1 — </a:t>
+              <a:t>DEMO MOMENT №1 —</a:t>
             </a:r>
             <a:pPr indent="0" marL="0">
               <a:buNone/>
@@ -17139,7 +17139,7 @@
                 <a:ea typeface="Calibri" pitchFamily="34" charset="-122"/>
                 <a:cs typeface="Calibri" pitchFamily="34" charset="-120"/>
               </a:rPr>
-              <a:t>SOM — 5-year target</a:t>
+              <a:t>SOM — 3-year target</a:t>
             </a:r>
             <a:endParaRPr lang="en-US" sz="950" dirty="0"/>
           </a:p>
@@ -17178,7 +17178,7 @@
                 <a:ea typeface="Calibri" pitchFamily="34" charset="-122"/>
                 <a:cs typeface="Calibri" pitchFamily="34" charset="-120"/>
               </a:rPr>
-              <a:t>₹1,500 Cr AUM</a:t>
+              <a:t>₹1,700 Cr AUM</a:t>
             </a:r>
             <a:endParaRPr lang="en-US" sz="1900" dirty="0"/>
           </a:p>
@@ -17220,7 +17220,7 @@
                 <a:ea typeface="Calibri" pitchFamily="34" charset="-122"/>
                 <a:cs typeface="Calibri" pitchFamily="34" charset="-120"/>
               </a:rPr>
-              <a:t>~30,000 active loans at ₹5L average — 0.2% of outlets. Oxyzo built ₹11,822Cr AUM in broad SME; we need a sliver</a:t>
+              <a:t>~26,000 active loans (₹5–10L avg) — 0.2% of outlets. Oxyzo built ₹11,822Cr AUM in broad SME; we need a sliver</a:t>
             </a:r>
             <a:endParaRPr lang="en-US" sz="800" dirty="0"/>
           </a:p>
@@ -17474,7 +17474,7 @@
                   <a:srgbClr val="000000"/>
                 </a:solidFill>
               </a:rPr>
-              <a:t>🧠</a:t>
+              <a:t/>
             </a:r>
             <a:endParaRPr lang="en-US" sz="2600" dirty="0"/>
           </a:p>
@@ -17634,7 +17634,7 @@
                 <a:ea typeface="Calibri" pitchFamily="34" charset="-122"/>
                 <a:cs typeface="Calibri" pitchFamily="34" charset="-120"/>
               </a:rPr>
-              <a:t>Claude AI writes a full credit memo for every decision — transparent, auditable</a:t>
+              <a:t>Rasoi IQ writes a full credit memo for every decision — transparent, auditable</a:t>
             </a:r>
             <a:endParaRPr lang="en-US" sz="950" dirty="0"/>
           </a:p>
@@ -17778,7 +17778,7 @@
                   <a:srgbClr val="000000"/>
                 </a:solidFill>
               </a:rPr>
-              <a:t>⏰</a:t>
+              <a:t/>
             </a:r>
             <a:endParaRPr lang="en-US" sz="2600" dirty="0"/>
           </a:p>
@@ -17879,7 +17879,7 @@
                 <a:ea typeface="Calibri" pitchFamily="34" charset="-122"/>
                 <a:cs typeface="Calibri" pitchFamily="34" charset="-120"/>
               </a:rPr>
-              <a:t>Virtual account (Castler) intercepts Swiggy/Zomato settlements at source</a:t>
+              <a:t>A regulated virtual account intercepts Swiggy/Zomato settlements at source</a:t>
             </a:r>
             <a:endParaRPr lang="en-US" sz="950" dirty="0"/>
           </a:p>
@@ -18082,7 +18082,7 @@
                   <a:srgbClr val="000000"/>
                 </a:solidFill>
               </a:rPr>
-              <a:t>🛡️</a:t>
+              <a:t/>
             </a:r>
             <a:endParaRPr lang="en-US" sz="2600" dirty="0"/>
           </a:p>
@@ -18242,7 +18242,7 @@
                 <a:ea typeface="Calibri" pitchFamily="34" charset="-122"/>
                 <a:cs typeface="Calibri" pitchFamily="34" charset="-120"/>
               </a:rPr>
-              <a:t>Weekly collection; clean payers earn better terms + cross-sell after 6 months</a:t>
+              <a:t>Weekly collection every Friday; clean payers earn better terms + cross-sell</a:t>
             </a:r>
             <a:endParaRPr lang="en-US" sz="950" dirty="0"/>
           </a:p>
@@ -19625,7 +19625,7 @@
                 <a:ea typeface="Calibri" pitchFamily="34" charset="-122"/>
                 <a:cs typeface="Calibri" pitchFamily="34" charset="-120"/>
               </a:rPr>
-              <a:t>   +  Claude AI credit memo on every run</a:t>
+              <a:t>   +  Rasoi IQ credit memo on every run</a:t>
             </a:r>
             <a:endParaRPr lang="en-US" sz="1150" dirty="0"/>
           </a:p>
@@ -19777,7 +19777,7 @@
                 <a:ea typeface="Calibri" pitchFamily="34" charset="-122"/>
                 <a:cs typeface="Calibri" pitchFamily="34" charset="-120"/>
               </a:rPr>
-              <a:t>🎯  LIVE DEMO — 90 SECONDS</a:t>
+              <a:t>LIVE DEMO — 90 SECONDS</a:t>
             </a:r>
             <a:endParaRPr lang="en-US" sz="1200" dirty="0"/>
           </a:p>
@@ -20001,7 +20001,7 @@
                 <a:ea typeface="Calibri" pitchFamily="34" charset="-122"/>
                 <a:cs typeface="Calibri" pitchFamily="34" charset="-120"/>
               </a:rPr>
-              <a:t>Spice Garden Cafe, Bengaluru</a:t>
+              <a:t>Green Leaf Cafe, Bengaluru</a:t>
             </a:r>
             <a:endParaRPr lang="en-US" sz="1000" dirty="0"/>
           </a:p>
@@ -20391,7 +20391,7 @@
                 <a:ea typeface="Calibri" pitchFamily="34" charset="-122"/>
                 <a:cs typeface="Calibri" pitchFamily="34" charset="-120"/>
               </a:rPr>
-              <a:t>2 positive · 1 average</a:t>
+              <a:t>3 positive · 0 flags</a:t>
             </a:r>
             <a:endParaRPr lang="en-US" sz="1000" dirty="0"/>
           </a:p>
@@ -20576,7 +20576,7 @@
                 <a:ea typeface="Calibri" pitchFamily="34" charset="-122"/>
                 <a:cs typeface="Calibri" pitchFamily="34" charset="-120"/>
               </a:rPr>
-              <a:t>3.70 / 5.00</a:t>
+              <a:t>4.05 / 5.00</a:t>
             </a:r>
             <a:endParaRPr lang="en-US" sz="1000" dirty="0"/>
           </a:p>
@@ -20654,7 +20654,7 @@
                 <a:ea typeface="Calibri" pitchFamily="34" charset="-122"/>
                 <a:cs typeface="Calibri" pitchFamily="34" charset="-120"/>
               </a:rPr>
-              <a:t>C — Approve w/ conditions</a:t>
+              <a:t>G — Auto-approve</a:t>
             </a:r>
             <a:endParaRPr lang="en-US" sz="1000" dirty="0"/>
           </a:p>
@@ -20927,7 +20927,7 @@
                 <a:ea typeface="Calibri" pitchFamily="34" charset="-122"/>
                 <a:cs typeface="Calibri" pitchFamily="34" charset="-120"/>
               </a:rPr>
-              <a:t>+ Claude credit memo</a:t>
+              <a:t>+ Rasoi IQ credit memo</a:t>
             </a:r>
             <a:endParaRPr lang="en-US" sz="1000" dirty="0"/>
           </a:p>
@@ -20966,7 +20966,7 @@
                 <a:ea typeface="Calibri" pitchFamily="34" charset="-122"/>
                 <a:cs typeface="Calibri" pitchFamily="34" charset="-120"/>
               </a:rPr>
-              <a:t>weak factors · path to G</a:t>
+              <a:t>clean file · TRUSTED (DIS 91)</a:t>
             </a:r>
             <a:endParaRPr lang="en-US" sz="1000" dirty="0"/>
           </a:p>
@@ -21213,7 +21213,7 @@
                 <a:ea typeface="Calibri" pitchFamily="34" charset="-122"/>
                 <a:cs typeface="Calibri" pitchFamily="34" charset="-120"/>
               </a:rPr>
-              <a:t>A virtual account (via Castler) intercepts aggregator settlements. Repayment becomes structural, not behavioural.</a:t>
+              <a:t>A regulated virtual account intercepts aggregator settlements. Repayment becomes structural, not behavioural.</a:t>
             </a:r>
             <a:endParaRPr lang="en-US" sz="1300" dirty="0"/>
           </a:p>
@@ -21351,7 +21351,7 @@
                 <a:ea typeface="Calibri" pitchFamily="34" charset="-122"/>
                 <a:cs typeface="Calibri" pitchFamily="34" charset="-120"/>
               </a:rPr>
-              <a:t>Swiggy/Zomato settlements route through the Castler virtual account; EMI comes out first, remainder sweeps to the outlet</a:t>
+              <a:t>Swiggy/Zomato settlements route through our virtual account every Friday; EMI comes out first, remainder sweeps to the outlet</a:t>
             </a:r>
             <a:endParaRPr lang="en-US" sz="900" dirty="0"/>
           </a:p>
@@ -21589,7 +21589,7 @@
                 <a:ea typeface="Calibri" pitchFamily="34" charset="-122"/>
                 <a:cs typeface="Calibri" pitchFamily="34" charset="-120"/>
               </a:rPr>
-              <a:t>Castler escrow rails</a:t>
+              <a:t>Regulated escrow rails</a:t>
             </a:r>
             <a:endParaRPr lang="en-US" sz="1150" dirty="0"/>
           </a:p>

</xml_diff>